<commit_message>
added pics to ppt
</commit_message>
<xml_diff>
--- a/MP2526_Verdediging.pptx
+++ b/MP2526_Verdediging.pptx
@@ -30006,8 +30006,8 @@
         </p:nvGrpSpPr>
         <p:grpSpPr>
           <a:xfrm>
-            <a:off x="251301" y="1268760"/>
-            <a:ext cx="5522621" cy="3384376"/>
+            <a:off x="251302" y="1268760"/>
+            <a:ext cx="5405118" cy="3312368"/>
             <a:chOff x="0" y="0"/>
             <a:chExt cx="2971800" cy="1821180"/>
           </a:xfrm>
@@ -30397,8 +30397,8 @@
         </p:nvSpPr>
         <p:spPr>
           <a:xfrm>
-            <a:off x="265462" y="4711077"/>
-            <a:ext cx="5508460" cy="1323439"/>
+            <a:off x="265462" y="4581128"/>
+            <a:ext cx="5390958" cy="1323439"/>
           </a:xfrm>
           <a:prstGeom prst="rect">
             <a:avLst/>
@@ -30422,14 +30422,7 @@
             </a:r>
             <a:r>
               <a:rPr lang="nl-BE" sz="1600" dirty="0"/>
-              <a:t>-node met </a:t>
-            </a:r>
-          </a:p>
-          <a:p>
-            <a:pPr algn="ctr"/>
-            <a:r>
-              <a:rPr lang="nl-BE" sz="1600" dirty="0"/>
-              <a:t>kinderen, b) De iconknop opties bij een </a:t>
+              <a:t>-node met kinderen, b) De iconknop opties bij een </a:t>
             </a:r>
             <a:r>
               <a:rPr lang="nl-BE" sz="1600" dirty="0" err="1"/>
@@ -30437,14 +30430,7 @@
             </a:r>
             <a:r>
               <a:rPr lang="nl-BE" sz="1600" dirty="0"/>
-              <a:t>-node </a:t>
-            </a:r>
-          </a:p>
-          <a:p>
-            <a:pPr algn="ctr"/>
-            <a:r>
-              <a:rPr lang="nl-BE" sz="1600" dirty="0"/>
-              <a:t>zonder kinderen, c) De iconknop opties bij een </a:t>
+              <a:t>-node zonder kinderen, c) De iconknop opties bij een </a:t>
             </a:r>
           </a:p>
           <a:p>
@@ -30505,6 +30491,36 @@
           </a:p>
         </p:txBody>
       </p:sp>
+      <p:pic>
+        <p:nvPicPr>
+          <p:cNvPr id="15" name="Afbeelding 14" descr="Afbeelding met tekst, schermopname, Lettertype, logo&#10;&#10;Door AI gegenereerde inhoud is mogelijk onjuist.">
+            <a:extLst>
+              <a:ext uri="{FF2B5EF4-FFF2-40B4-BE49-F238E27FC236}">
+                <a16:creationId xmlns:a16="http://schemas.microsoft.com/office/drawing/2014/main" id="{3BB980C4-4B3D-B4B7-512A-16FE041F03C4}"/>
+              </a:ext>
+            </a:extLst>
+          </p:cNvPr>
+          <p:cNvPicPr>
+            <a:picLocks noChangeAspect="1"/>
+          </p:cNvPicPr>
+          <p:nvPr/>
+        </p:nvPicPr>
+        <p:blipFill>
+          <a:blip r:embed="rId7"/>
+          <a:stretch>
+            <a:fillRect/>
+          </a:stretch>
+        </p:blipFill>
+        <p:spPr>
+          <a:xfrm>
+            <a:off x="6055263" y="1052736"/>
+            <a:ext cx="5824745" cy="3806554"/>
+          </a:xfrm>
+          <a:prstGeom prst="rect">
+            <a:avLst/>
+          </a:prstGeom>
+        </p:spPr>
+      </p:pic>
     </p:spTree>
     <p:extLst>
       <p:ext uri="{BB962C8B-B14F-4D97-AF65-F5344CB8AC3E}">
@@ -30902,7 +30918,7 @@
         </p:blipFill>
         <p:spPr>
           <a:xfrm>
-            <a:off x="4007768" y="1268760"/>
+            <a:off x="839416" y="1268760"/>
             <a:ext cx="4176464" cy="3672058"/>
           </a:xfrm>
           <a:prstGeom prst="rect">
@@ -30964,7 +30980,7 @@
         </p:nvSpPr>
         <p:spPr>
           <a:xfrm>
-            <a:off x="4007768" y="5004465"/>
+            <a:off x="839416" y="5004465"/>
             <a:ext cx="4176464" cy="584775"/>
           </a:xfrm>
           <a:prstGeom prst="rect">
@@ -31024,6 +31040,36 @@
           </a:p>
         </p:txBody>
       </p:sp>
+      <p:pic>
+        <p:nvPicPr>
+          <p:cNvPr id="5" name="Afbeelding 4" descr="Afbeelding met tekst, schermopname, Lettertype, nummer&#10;&#10;Door AI gegenereerde inhoud is mogelijk onjuist.">
+            <a:extLst>
+              <a:ext uri="{FF2B5EF4-FFF2-40B4-BE49-F238E27FC236}">
+                <a16:creationId xmlns:a16="http://schemas.microsoft.com/office/drawing/2014/main" id="{6BE418D6-C7FB-19D5-B14F-D6DFE8AC710F}"/>
+              </a:ext>
+            </a:extLst>
+          </p:cNvPr>
+          <p:cNvPicPr>
+            <a:picLocks noChangeAspect="1"/>
+          </p:cNvPicPr>
+          <p:nvPr/>
+        </p:nvPicPr>
+        <p:blipFill>
+          <a:blip r:embed="rId4"/>
+          <a:stretch>
+            <a:fillRect/>
+          </a:stretch>
+        </p:blipFill>
+        <p:spPr>
+          <a:xfrm>
+            <a:off x="7176122" y="908720"/>
+            <a:ext cx="3024336" cy="4646082"/>
+          </a:xfrm>
+          <a:prstGeom prst="rect">
+            <a:avLst/>
+          </a:prstGeom>
+        </p:spPr>
+      </p:pic>
     </p:spTree>
     <p:extLst>
       <p:ext uri="{BB962C8B-B14F-4D97-AF65-F5344CB8AC3E}">
@@ -31125,6 +31171,66 @@
           </a:p>
         </p:txBody>
       </p:sp>
+      <p:pic>
+        <p:nvPicPr>
+          <p:cNvPr id="4" name="Afbeelding 3" descr="Afbeelding met tekst, schermopname, Lettertype, ontwerp&#10;&#10;Door AI gegenereerde inhoud is mogelijk onjuist.">
+            <a:extLst>
+              <a:ext uri="{FF2B5EF4-FFF2-40B4-BE49-F238E27FC236}">
+                <a16:creationId xmlns:a16="http://schemas.microsoft.com/office/drawing/2014/main" id="{4091FB84-75C0-9235-693A-44E0A639535D}"/>
+              </a:ext>
+            </a:extLst>
+          </p:cNvPr>
+          <p:cNvPicPr>
+            <a:picLocks noChangeAspect="1"/>
+          </p:cNvPicPr>
+          <p:nvPr/>
+        </p:nvPicPr>
+        <p:blipFill>
+          <a:blip r:embed="rId3"/>
+          <a:stretch>
+            <a:fillRect/>
+          </a:stretch>
+        </p:blipFill>
+        <p:spPr>
+          <a:xfrm>
+            <a:off x="695400" y="836712"/>
+            <a:ext cx="5159896" cy="2454655"/>
+          </a:xfrm>
+          <a:prstGeom prst="rect">
+            <a:avLst/>
+          </a:prstGeom>
+        </p:spPr>
+      </p:pic>
+      <p:pic>
+        <p:nvPicPr>
+          <p:cNvPr id="7" name="Afbeelding 6" descr="Afbeelding met tekst, schermopname, diagram, nummer&#10;&#10;Door AI gegenereerde inhoud is mogelijk onjuist.">
+            <a:extLst>
+              <a:ext uri="{FF2B5EF4-FFF2-40B4-BE49-F238E27FC236}">
+                <a16:creationId xmlns:a16="http://schemas.microsoft.com/office/drawing/2014/main" id="{3C2248D2-2F46-6544-669F-A88342AF66B2}"/>
+              </a:ext>
+            </a:extLst>
+          </p:cNvPr>
+          <p:cNvPicPr>
+            <a:picLocks noChangeAspect="1"/>
+          </p:cNvPicPr>
+          <p:nvPr/>
+        </p:nvPicPr>
+        <p:blipFill>
+          <a:blip r:embed="rId4"/>
+          <a:stretch>
+            <a:fillRect/>
+          </a:stretch>
+        </p:blipFill>
+        <p:spPr>
+          <a:xfrm>
+            <a:off x="5854180" y="3129188"/>
+            <a:ext cx="6096000" cy="2892100"/>
+          </a:xfrm>
+          <a:prstGeom prst="rect">
+            <a:avLst/>
+          </a:prstGeom>
+        </p:spPr>
+      </p:pic>
     </p:spTree>
     <p:extLst>
       <p:ext uri="{BB962C8B-B14F-4D97-AF65-F5344CB8AC3E}">
@@ -35830,129 +35936,37 @@
           <a:chExt cx="0" cy="0"/>
         </a:xfrm>
       </p:grpSpPr>
-      <p:sp>
-        <p:nvSpPr>
-          <p:cNvPr id="4" name="Tijdelijke aanduiding voor inhoud 3">
+      <p:pic>
+        <p:nvPicPr>
+          <p:cNvPr id="7" name="Afbeelding 6" descr="Afbeelding met tekst, schermopname, Lettertype, ontwerp&#10;&#10;Door AI gegenereerde inhoud is mogelijk onjuist.">
             <a:extLst>
               <a:ext uri="{FF2B5EF4-FFF2-40B4-BE49-F238E27FC236}">
-                <a16:creationId xmlns:a16="http://schemas.microsoft.com/office/drawing/2014/main" id="{F4A2E2A1-BB2F-80CB-60DE-79EAEB5D4935}"/>
+                <a16:creationId xmlns:a16="http://schemas.microsoft.com/office/drawing/2014/main" id="{A59DD510-B622-EF72-3BA8-EC4195318325}"/>
               </a:ext>
             </a:extLst>
           </p:cNvPr>
-          <p:cNvSpPr>
-            <a:spLocks noGrp="1"/>
-          </p:cNvSpPr>
-          <p:nvPr>
-            <p:ph sz="half" idx="1"/>
-          </p:nvPr>
-        </p:nvSpPr>
+          <p:cNvPicPr>
+            <a:picLocks noChangeAspect="1"/>
+          </p:cNvPicPr>
+          <p:nvPr/>
+        </p:nvPicPr>
+        <p:blipFill>
+          <a:blip r:embed="rId3"/>
+          <a:stretch>
+            <a:fillRect/>
+          </a:stretch>
+        </p:blipFill>
         <p:spPr>
           <a:xfrm>
-            <a:off x="609600" y="980731"/>
-            <a:ext cx="10598968" cy="5145435"/>
+            <a:off x="2395686" y="908723"/>
+            <a:ext cx="7400628" cy="5217443"/>
           </a:xfrm>
+          <a:prstGeom prst="rect">
+            <a:avLst/>
+          </a:prstGeom>
+          <a:noFill/>
         </p:spPr>
-        <p:txBody>
-          <a:bodyPr/>
-          <a:lstStyle/>
-          <a:p>
-            <a:endParaRPr lang="nl-BE" sz="2800" dirty="0"/>
-          </a:p>
-          <a:p>
-            <a:r>
-              <a:rPr lang="nl-BE" sz="2800" dirty="0"/>
-              <a:t>Voorbeeld </a:t>
-            </a:r>
-            <a:r>
-              <a:rPr lang="nl-BE" sz="2800" dirty="0" err="1"/>
-              <a:t>branch</a:t>
-            </a:r>
-            <a:r>
-              <a:rPr lang="nl-BE" sz="2800" dirty="0"/>
-              <a:t>:</a:t>
-            </a:r>
-          </a:p>
-          <a:p>
-            <a:pPr lvl="1">
-              <a:buFont typeface="Wingdings" panose="05000000000000000000" pitchFamily="2" charset="2"/>
-              <a:buChar char="Ø"/>
-            </a:pPr>
-            <a:r>
-              <a:rPr lang="nl-BE" sz="2000" dirty="0" err="1"/>
-              <a:t>Fortunately</a:t>
-            </a:r>
-            <a:r>
-              <a:rPr lang="nl-BE" sz="2000" dirty="0"/>
-              <a:t>: "Uitrol wachtwoordmanager verbetert gebruiksgemak”</a:t>
-            </a:r>
-          </a:p>
-          <a:p>
-            <a:pPr lvl="2">
-              <a:buFont typeface="Wingdings" panose="05000000000000000000" pitchFamily="2" charset="2"/>
-              <a:buChar char="Ø"/>
-            </a:pPr>
-            <a:r>
-              <a:rPr lang="en-GB" sz="2000" dirty="0"/>
-              <a:t>Unfortunately: "</a:t>
-            </a:r>
-            <a:r>
-              <a:rPr lang="en-GB" sz="2000" dirty="0" err="1"/>
-              <a:t>Werknemers</a:t>
-            </a:r>
-            <a:r>
-              <a:rPr lang="en-GB" sz="2000" dirty="0"/>
-              <a:t> </a:t>
-            </a:r>
-            <a:r>
-              <a:rPr lang="en-GB" sz="2000" dirty="0" err="1"/>
-              <a:t>weigeren</a:t>
-            </a:r>
-            <a:r>
-              <a:rPr lang="en-GB" sz="2000" dirty="0"/>
-              <a:t> </a:t>
-            </a:r>
-            <a:r>
-              <a:rPr lang="en-GB" sz="2000" dirty="0" err="1"/>
-              <a:t>wachtwoordmanagers</a:t>
-            </a:r>
-            <a:r>
-              <a:rPr lang="en-GB" sz="2000" dirty="0"/>
-              <a:t>;</a:t>
-            </a:r>
-            <a:endParaRPr lang="nl-BE" sz="2000" dirty="0"/>
-          </a:p>
-          <a:p>
-            <a:pPr lvl="3">
-              <a:buFont typeface="Wingdings" panose="05000000000000000000" pitchFamily="2" charset="2"/>
-              <a:buChar char="Ø"/>
-            </a:pPr>
-            <a:r>
-              <a:rPr lang="en-GB" sz="2000" dirty="0"/>
-              <a:t>Fortunately: "Training </a:t>
-            </a:r>
-            <a:r>
-              <a:rPr lang="en-GB" sz="2000" dirty="0" err="1"/>
-              <a:t>verlaagt</a:t>
-            </a:r>
-            <a:r>
-              <a:rPr lang="en-GB" sz="2000" dirty="0"/>
-              <a:t> </a:t>
-            </a:r>
-            <a:r>
-              <a:rPr lang="en-GB" sz="2000" dirty="0" err="1"/>
-              <a:t>drempel</a:t>
-            </a:r>
-            <a:r>
-              <a:rPr lang="en-GB" sz="2000" dirty="0"/>
-              <a:t>".</a:t>
-            </a:r>
-            <a:endParaRPr lang="nl-BE" sz="2000" dirty="0"/>
-          </a:p>
-          <a:p>
-            <a:endParaRPr lang="nl-BE" sz="2800" dirty="0"/>
-          </a:p>
-        </p:txBody>
-      </p:sp>
+      </p:pic>
       <p:sp>
         <p:nvSpPr>
           <p:cNvPr id="6" name="Titel 5">
@@ -35971,12 +35985,14 @@
         </p:nvSpPr>
         <p:spPr>
           <a:xfrm>
-            <a:off x="624417" y="116632"/>
-            <a:ext cx="10972800" cy="433387"/>
+            <a:off x="143935" y="198981"/>
+            <a:ext cx="11987005" cy="549844"/>
           </a:xfrm>
         </p:spPr>
         <p:txBody>
-          <a:bodyPr/>
+          <a:bodyPr wrap="square" anchor="ctr">
+            <a:normAutofit fontScale="90000"/>
+          </a:bodyPr>
           <a:lstStyle/>
           <a:p>
             <a:r>
@@ -36003,17 +36019,33 @@
             <a:spLocks noGrp="1"/>
           </p:cNvSpPr>
           <p:nvPr>
-            <p:ph type="sldNum" sz="quarter" idx="13"/>
+            <p:ph type="sldNum" sz="quarter" idx="12"/>
           </p:nvPr>
         </p:nvSpPr>
-        <p:spPr/>
+        <p:spPr>
+          <a:xfrm>
+            <a:off x="-2400944" y="6381328"/>
+            <a:ext cx="2844800" cy="365125"/>
+          </a:xfrm>
+        </p:spPr>
         <p:txBody>
-          <a:bodyPr/>
+          <a:bodyPr wrap="square" anchor="ctr">
+            <a:normAutofit/>
+          </a:bodyPr>
           <a:lstStyle/>
           <a:p>
+            <a:pPr>
+              <a:spcAft>
+                <a:spcPts val="600"/>
+              </a:spcAft>
+            </a:pPr>
             <a:fld id="{2C8C6316-E44E-4DB2-87E9-228972E3BC6C}" type="slidenum">
               <a:rPr lang="nl-BE" altLang="en-US" smtClean="0"/>
-              <a:pPr/>
+              <a:pPr>
+                <a:spcAft>
+                  <a:spcPts val="600"/>
+                </a:spcAft>
+              </a:pPr>
               <a:t>7</a:t>
             </a:fld>
             <a:endParaRPr lang="nl-BE" altLang="en-US"/>

</xml_diff>

<commit_message>
final changes to ppt (i think)
</commit_message>
<xml_diff>
--- a/MP2526_Verdediging.pptx
+++ b/MP2526_Verdediging.pptx
@@ -22397,7 +22397,7 @@
               <a:pPr>
                 <a:defRPr/>
               </a:pPr>
-              <a:t>29-1-2026</a:t>
+              <a:t>30-1-2026</a:t>
             </a:fld>
             <a:endParaRPr lang="nl-NL"/>
           </a:p>
@@ -27777,129 +27777,6 @@
           </a:prstGeom>
         </p:spPr>
       </p:pic>
-      <p:sp>
-        <p:nvSpPr>
-          <p:cNvPr id="12" name="Tekstvak 11">
-            <a:extLst>
-              <a:ext uri="{FF2B5EF4-FFF2-40B4-BE49-F238E27FC236}">
-                <a16:creationId xmlns:a16="http://schemas.microsoft.com/office/drawing/2014/main" id="{901C8C06-10DC-7B5A-DC4E-EC1EA9F18E40}"/>
-              </a:ext>
-            </a:extLst>
-          </p:cNvPr>
-          <p:cNvSpPr txBox="1"/>
-          <p:nvPr/>
-        </p:nvSpPr>
-        <p:spPr>
-          <a:xfrm>
-            <a:off x="3592573" y="5805264"/>
-            <a:ext cx="4833374" cy="230832"/>
-          </a:xfrm>
-          <a:prstGeom prst="rect">
-            <a:avLst/>
-          </a:prstGeom>
-          <a:noFill/>
-        </p:spPr>
-        <p:txBody>
-          <a:bodyPr wrap="none" rtlCol="0">
-            <a:spAutoFit/>
-          </a:bodyPr>
-          <a:lstStyle/>
-          <a:p>
-            <a:r>
-              <a:rPr lang="nl-BE" sz="900" dirty="0">
-                <a:hlinkClick r:id="rId5"/>
-              </a:rPr>
-              <a:t>https://www.cosmicjs.com/blog/nextjs-15-vs-16-building-modern-blogs-in-the-turbopack-era</a:t>
-            </a:r>
-            <a:endParaRPr lang="nl-BE" sz="900" dirty="0"/>
-          </a:p>
-        </p:txBody>
-      </p:sp>
-      <p:sp>
-        <p:nvSpPr>
-          <p:cNvPr id="13" name="Tekstvak 12">
-            <a:extLst>
-              <a:ext uri="{FF2B5EF4-FFF2-40B4-BE49-F238E27FC236}">
-                <a16:creationId xmlns:a16="http://schemas.microsoft.com/office/drawing/2014/main" id="{50172859-1719-B292-5773-C9342BC32D0F}"/>
-              </a:ext>
-            </a:extLst>
-          </p:cNvPr>
-          <p:cNvSpPr txBox="1"/>
-          <p:nvPr/>
-        </p:nvSpPr>
-        <p:spPr>
-          <a:xfrm>
-            <a:off x="9222625" y="5723964"/>
-            <a:ext cx="1697911" cy="369332"/>
-          </a:xfrm>
-          <a:prstGeom prst="rect">
-            <a:avLst/>
-          </a:prstGeom>
-          <a:noFill/>
-        </p:spPr>
-        <p:txBody>
-          <a:bodyPr wrap="square" rtlCol="0">
-            <a:spAutoFit/>
-          </a:bodyPr>
-          <a:lstStyle/>
-          <a:p>
-            <a:r>
-              <a:rPr lang="nl-BE" dirty="0">
-                <a:hlinkClick r:id="rId6"/>
-              </a:rPr>
-              <a:t>https://d3js.org</a:t>
-            </a:r>
-            <a:endParaRPr lang="nl-BE" dirty="0"/>
-          </a:p>
-        </p:txBody>
-      </p:sp>
-      <p:sp>
-        <p:nvSpPr>
-          <p:cNvPr id="14" name="Tekstvak 13">
-            <a:extLst>
-              <a:ext uri="{FF2B5EF4-FFF2-40B4-BE49-F238E27FC236}">
-                <a16:creationId xmlns:a16="http://schemas.microsoft.com/office/drawing/2014/main" id="{1AEC0763-B9A1-2F21-4CE6-78D7AF048908}"/>
-              </a:ext>
-            </a:extLst>
-          </p:cNvPr>
-          <p:cNvSpPr txBox="1"/>
-          <p:nvPr/>
-        </p:nvSpPr>
-        <p:spPr>
-          <a:xfrm>
-            <a:off x="1036441" y="5651956"/>
-            <a:ext cx="2016224" cy="369332"/>
-          </a:xfrm>
-          <a:prstGeom prst="rect">
-            <a:avLst/>
-          </a:prstGeom>
-          <a:noFill/>
-        </p:spPr>
-        <p:txBody>
-          <a:bodyPr wrap="square" rtlCol="0">
-            <a:spAutoFit/>
-          </a:bodyPr>
-          <a:lstStyle/>
-          <a:p>
-            <a:r>
-              <a:rPr lang="nl-BE" dirty="0">
-                <a:solidFill>
-                  <a:srgbClr val="0000FF"/>
-                </a:solidFill>
-                <a:hlinkClick r:id="rId7">
-                  <a:extLst>
-                    <a:ext uri="{A12FA001-AC4F-418D-AE19-62706E023703}">
-                      <ahyp:hlinkClr xmlns:ahyp="http://schemas.microsoft.com/office/drawing/2018/hyperlinkcolor" val="tx"/>
-                    </a:ext>
-                  </a:extLst>
-                </a:hlinkClick>
-              </a:rPr>
-              <a:t>https://react.dev</a:t>
-            </a:r>
-            <a:endParaRPr lang="nl-BE" dirty="0"/>
-          </a:p>
-        </p:txBody>
-      </p:sp>
       <p:pic>
         <p:nvPicPr>
           <p:cNvPr id="1026" name="Picture 2" descr="cover image">
@@ -27915,7 +27792,7 @@
           <p:nvPr/>
         </p:nvPicPr>
         <p:blipFill>
-          <a:blip r:embed="rId8" cstate="print">
+          <a:blip r:embed="rId5" cstate="print">
             <a:extLst>
               <a:ext uri="{28A0092B-C50C-407E-A947-70E740481C1C}">
                 <a14:useLocalDpi xmlns:a14="http://schemas.microsoft.com/office/drawing/2010/main" val="0"/>
@@ -27986,7 +27863,7 @@
             </a:r>
             <a:r>
               <a:rPr lang="nl-BE" sz="1600" dirty="0"/>
-              <a:t> logo</a:t>
+              <a:t> logo [11]</a:t>
             </a:r>
           </a:p>
         </p:txBody>
@@ -28022,7 +27899,7 @@
             <a:pPr algn="ctr"/>
             <a:r>
               <a:rPr lang="nl-BE" sz="1600" dirty="0"/>
-              <a:t>Fig. 6: Next.js logo</a:t>
+              <a:t>Fig. 6: Next.js logo [12]</a:t>
             </a:r>
           </a:p>
         </p:txBody>
@@ -28058,7 +27935,7 @@
             <a:pPr algn="ctr"/>
             <a:r>
               <a:rPr lang="nl-BE" sz="1600" dirty="0"/>
-              <a:t>Fig. 7: D3-library logo</a:t>
+              <a:t>Fig. 7: D3-library logo [13]</a:t>
             </a:r>
           </a:p>
         </p:txBody>
@@ -30565,6 +30442,190 @@
           </a:p>
         </p:txBody>
       </p:sp>
+      <p:sp>
+        <p:nvSpPr>
+          <p:cNvPr id="16" name="Pijl: omhoog 15">
+            <a:extLst>
+              <a:ext uri="{FF2B5EF4-FFF2-40B4-BE49-F238E27FC236}">
+                <a16:creationId xmlns:a16="http://schemas.microsoft.com/office/drawing/2014/main" id="{B1AF2C07-0BDF-5172-112A-5E89D3975852}"/>
+              </a:ext>
+            </a:extLst>
+          </p:cNvPr>
+          <p:cNvSpPr/>
+          <p:nvPr/>
+        </p:nvSpPr>
+        <p:spPr>
+          <a:xfrm rot="5400000">
+            <a:off x="6980151" y="2112965"/>
+            <a:ext cx="432048" cy="656344"/>
+          </a:xfrm>
+          <a:prstGeom prst="upArrow">
+            <a:avLst/>
+          </a:prstGeom>
+        </p:spPr>
+        <p:style>
+          <a:lnRef idx="2">
+            <a:schemeClr val="dk1">
+              <a:shade val="15000"/>
+            </a:schemeClr>
+          </a:lnRef>
+          <a:fillRef idx="1">
+            <a:schemeClr val="dk1"/>
+          </a:fillRef>
+          <a:effectRef idx="0">
+            <a:schemeClr val="dk1"/>
+          </a:effectRef>
+          <a:fontRef idx="minor">
+            <a:schemeClr val="lt1"/>
+          </a:fontRef>
+        </p:style>
+        <p:txBody>
+          <a:bodyPr rtlCol="0" anchor="ctr"/>
+          <a:lstStyle/>
+          <a:p>
+            <a:pPr algn="ctr"/>
+            <a:endParaRPr lang="nl-BE"/>
+          </a:p>
+        </p:txBody>
+      </p:sp>
+      <p:sp>
+        <p:nvSpPr>
+          <p:cNvPr id="17" name="Pijl: omhoog 16">
+            <a:extLst>
+              <a:ext uri="{FF2B5EF4-FFF2-40B4-BE49-F238E27FC236}">
+                <a16:creationId xmlns:a16="http://schemas.microsoft.com/office/drawing/2014/main" id="{4DB8ABFE-870F-351C-412D-5E9AE2AF7767}"/>
+              </a:ext>
+            </a:extLst>
+          </p:cNvPr>
+          <p:cNvSpPr/>
+          <p:nvPr/>
+        </p:nvSpPr>
+        <p:spPr>
+          <a:xfrm rot="5400000">
+            <a:off x="8443808" y="3244844"/>
+            <a:ext cx="432048" cy="656344"/>
+          </a:xfrm>
+          <a:prstGeom prst="upArrow">
+            <a:avLst/>
+          </a:prstGeom>
+        </p:spPr>
+        <p:style>
+          <a:lnRef idx="2">
+            <a:schemeClr val="dk1">
+              <a:shade val="15000"/>
+            </a:schemeClr>
+          </a:lnRef>
+          <a:fillRef idx="1">
+            <a:schemeClr val="dk1"/>
+          </a:fillRef>
+          <a:effectRef idx="0">
+            <a:schemeClr val="dk1"/>
+          </a:effectRef>
+          <a:fontRef idx="minor">
+            <a:schemeClr val="lt1"/>
+          </a:fontRef>
+        </p:style>
+        <p:txBody>
+          <a:bodyPr rtlCol="0" anchor="ctr"/>
+          <a:lstStyle/>
+          <a:p>
+            <a:pPr algn="ctr"/>
+            <a:endParaRPr lang="nl-BE"/>
+          </a:p>
+        </p:txBody>
+      </p:sp>
+      <p:sp>
+        <p:nvSpPr>
+          <p:cNvPr id="18" name="Pijl: omhoog 17">
+            <a:extLst>
+              <a:ext uri="{FF2B5EF4-FFF2-40B4-BE49-F238E27FC236}">
+                <a16:creationId xmlns:a16="http://schemas.microsoft.com/office/drawing/2014/main" id="{DF8233AB-7AED-150C-A00C-B8CD77388612}"/>
+              </a:ext>
+            </a:extLst>
+          </p:cNvPr>
+          <p:cNvSpPr/>
+          <p:nvPr/>
+        </p:nvSpPr>
+        <p:spPr>
+          <a:xfrm rot="5400000">
+            <a:off x="7761623" y="4281570"/>
+            <a:ext cx="432048" cy="656344"/>
+          </a:xfrm>
+          <a:prstGeom prst="upArrow">
+            <a:avLst/>
+          </a:prstGeom>
+        </p:spPr>
+        <p:style>
+          <a:lnRef idx="2">
+            <a:schemeClr val="dk1">
+              <a:shade val="15000"/>
+            </a:schemeClr>
+          </a:lnRef>
+          <a:fillRef idx="1">
+            <a:schemeClr val="dk1"/>
+          </a:fillRef>
+          <a:effectRef idx="0">
+            <a:schemeClr val="dk1"/>
+          </a:effectRef>
+          <a:fontRef idx="minor">
+            <a:schemeClr val="lt1"/>
+          </a:fontRef>
+        </p:style>
+        <p:txBody>
+          <a:bodyPr rtlCol="0" anchor="ctr"/>
+          <a:lstStyle/>
+          <a:p>
+            <a:pPr algn="ctr"/>
+            <a:endParaRPr lang="nl-BE"/>
+          </a:p>
+        </p:txBody>
+      </p:sp>
+      <p:sp>
+        <p:nvSpPr>
+          <p:cNvPr id="19" name="Pijl: omhoog 18">
+            <a:extLst>
+              <a:ext uri="{FF2B5EF4-FFF2-40B4-BE49-F238E27FC236}">
+                <a16:creationId xmlns:a16="http://schemas.microsoft.com/office/drawing/2014/main" id="{52589B5B-AEA8-8407-D37C-21A969F8C8D9}"/>
+              </a:ext>
+            </a:extLst>
+          </p:cNvPr>
+          <p:cNvSpPr/>
+          <p:nvPr/>
+        </p:nvSpPr>
+        <p:spPr>
+          <a:xfrm rot="5400000">
+            <a:off x="7761623" y="2637145"/>
+            <a:ext cx="432048" cy="656344"/>
+          </a:xfrm>
+          <a:prstGeom prst="upArrow">
+            <a:avLst/>
+          </a:prstGeom>
+        </p:spPr>
+        <p:style>
+          <a:lnRef idx="2">
+            <a:schemeClr val="dk1">
+              <a:shade val="15000"/>
+            </a:schemeClr>
+          </a:lnRef>
+          <a:fillRef idx="1">
+            <a:schemeClr val="dk1"/>
+          </a:fillRef>
+          <a:effectRef idx="0">
+            <a:schemeClr val="dk1"/>
+          </a:effectRef>
+          <a:fontRef idx="minor">
+            <a:schemeClr val="lt1"/>
+          </a:fontRef>
+        </p:style>
+        <p:txBody>
+          <a:bodyPr rtlCol="0" anchor="ctr"/>
+          <a:lstStyle/>
+          <a:p>
+            <a:pPr algn="ctr"/>
+            <a:endParaRPr lang="nl-BE"/>
+          </a:p>
+        </p:txBody>
+      </p:sp>
     </p:spTree>
     <p:extLst>
       <p:ext uri="{BB962C8B-B14F-4D97-AF65-F5344CB8AC3E}">
@@ -30575,6 +30636,622 @@
   <p:clrMapOvr>
     <a:masterClrMapping/>
   </p:clrMapOvr>
+  <p:timing>
+    <p:tnLst>
+      <p:par>
+        <p:cTn id="1" dur="indefinite" restart="never" nodeType="tmRoot">
+          <p:childTnLst>
+            <p:seq concurrent="1" nextAc="seek">
+              <p:cTn id="2" dur="indefinite" nodeType="mainSeq">
+                <p:childTnLst>
+                  <p:par>
+                    <p:cTn id="3" fill="hold">
+                      <p:stCondLst>
+                        <p:cond delay="indefinite"/>
+                      </p:stCondLst>
+                      <p:childTnLst>
+                        <p:par>
+                          <p:cTn id="4" fill="hold">
+                            <p:stCondLst>
+                              <p:cond delay="0"/>
+                            </p:stCondLst>
+                            <p:childTnLst>
+                              <p:par>
+                                <p:cTn id="5" presetID="42" presetClass="entr" presetSubtype="0" fill="hold" grpId="0" nodeType="clickEffect">
+                                  <p:stCondLst>
+                                    <p:cond delay="0"/>
+                                  </p:stCondLst>
+                                  <p:childTnLst>
+                                    <p:set>
+                                      <p:cBhvr>
+                                        <p:cTn id="6" dur="1" fill="hold">
+                                          <p:stCondLst>
+                                            <p:cond delay="0"/>
+                                          </p:stCondLst>
+                                        </p:cTn>
+                                        <p:tgtEl>
+                                          <p:spTgt spid="16"/>
+                                        </p:tgtEl>
+                                        <p:attrNameLst>
+                                          <p:attrName>style.visibility</p:attrName>
+                                        </p:attrNameLst>
+                                      </p:cBhvr>
+                                      <p:to>
+                                        <p:strVal val="visible"/>
+                                      </p:to>
+                                    </p:set>
+                                    <p:animEffect transition="in" filter="fade">
+                                      <p:cBhvr>
+                                        <p:cTn id="7" dur="250"/>
+                                        <p:tgtEl>
+                                          <p:spTgt spid="16"/>
+                                        </p:tgtEl>
+                                      </p:cBhvr>
+                                    </p:animEffect>
+                                    <p:anim calcmode="lin" valueType="num">
+                                      <p:cBhvr>
+                                        <p:cTn id="8" dur="250" fill="hold"/>
+                                        <p:tgtEl>
+                                          <p:spTgt spid="16"/>
+                                        </p:tgtEl>
+                                        <p:attrNameLst>
+                                          <p:attrName>ppt_x</p:attrName>
+                                        </p:attrNameLst>
+                                      </p:cBhvr>
+                                      <p:tavLst>
+                                        <p:tav tm="0">
+                                          <p:val>
+                                            <p:strVal val="#ppt_x"/>
+                                          </p:val>
+                                        </p:tav>
+                                        <p:tav tm="100000">
+                                          <p:val>
+                                            <p:strVal val="#ppt_x"/>
+                                          </p:val>
+                                        </p:tav>
+                                      </p:tavLst>
+                                    </p:anim>
+                                    <p:anim calcmode="lin" valueType="num">
+                                      <p:cBhvr>
+                                        <p:cTn id="9" dur="250" fill="hold"/>
+                                        <p:tgtEl>
+                                          <p:spTgt spid="16"/>
+                                        </p:tgtEl>
+                                        <p:attrNameLst>
+                                          <p:attrName>ppt_y</p:attrName>
+                                        </p:attrNameLst>
+                                      </p:cBhvr>
+                                      <p:tavLst>
+                                        <p:tav tm="0">
+                                          <p:val>
+                                            <p:strVal val="#ppt_y+.1"/>
+                                          </p:val>
+                                        </p:tav>
+                                        <p:tav tm="100000">
+                                          <p:val>
+                                            <p:strVal val="#ppt_y"/>
+                                          </p:val>
+                                        </p:tav>
+                                      </p:tavLst>
+                                    </p:anim>
+                                  </p:childTnLst>
+                                </p:cTn>
+                              </p:par>
+                            </p:childTnLst>
+                          </p:cTn>
+                        </p:par>
+                      </p:childTnLst>
+                    </p:cTn>
+                  </p:par>
+                  <p:par>
+                    <p:cTn id="10" fill="hold">
+                      <p:stCondLst>
+                        <p:cond delay="indefinite"/>
+                      </p:stCondLst>
+                      <p:childTnLst>
+                        <p:par>
+                          <p:cTn id="11" fill="hold">
+                            <p:stCondLst>
+                              <p:cond delay="0"/>
+                            </p:stCondLst>
+                            <p:childTnLst>
+                              <p:par>
+                                <p:cTn id="12" presetID="1" presetClass="exit" presetSubtype="0" fill="hold" grpId="1" nodeType="clickEffect">
+                                  <p:stCondLst>
+                                    <p:cond delay="0"/>
+                                  </p:stCondLst>
+                                  <p:childTnLst>
+                                    <p:set>
+                                      <p:cBhvr>
+                                        <p:cTn id="13" dur="1" fill="hold">
+                                          <p:stCondLst>
+                                            <p:cond delay="0"/>
+                                          </p:stCondLst>
+                                        </p:cTn>
+                                        <p:tgtEl>
+                                          <p:spTgt spid="16"/>
+                                        </p:tgtEl>
+                                        <p:attrNameLst>
+                                          <p:attrName>style.visibility</p:attrName>
+                                        </p:attrNameLst>
+                                      </p:cBhvr>
+                                      <p:to>
+                                        <p:strVal val="hidden"/>
+                                      </p:to>
+                                    </p:set>
+                                  </p:childTnLst>
+                                </p:cTn>
+                              </p:par>
+                            </p:childTnLst>
+                          </p:cTn>
+                        </p:par>
+                      </p:childTnLst>
+                    </p:cTn>
+                  </p:par>
+                  <p:par>
+                    <p:cTn id="14" fill="hold">
+                      <p:stCondLst>
+                        <p:cond delay="indefinite"/>
+                      </p:stCondLst>
+                      <p:childTnLst>
+                        <p:par>
+                          <p:cTn id="15" fill="hold">
+                            <p:stCondLst>
+                              <p:cond delay="0"/>
+                            </p:stCondLst>
+                            <p:childTnLst>
+                              <p:par>
+                                <p:cTn id="16" presetID="42" presetClass="entr" presetSubtype="0" fill="hold" grpId="0" nodeType="clickEffect">
+                                  <p:stCondLst>
+                                    <p:cond delay="0"/>
+                                  </p:stCondLst>
+                                  <p:childTnLst>
+                                    <p:set>
+                                      <p:cBhvr>
+                                        <p:cTn id="17" dur="1" fill="hold">
+                                          <p:stCondLst>
+                                            <p:cond delay="0"/>
+                                          </p:stCondLst>
+                                        </p:cTn>
+                                        <p:tgtEl>
+                                          <p:spTgt spid="17"/>
+                                        </p:tgtEl>
+                                        <p:attrNameLst>
+                                          <p:attrName>style.visibility</p:attrName>
+                                        </p:attrNameLst>
+                                      </p:cBhvr>
+                                      <p:to>
+                                        <p:strVal val="visible"/>
+                                      </p:to>
+                                    </p:set>
+                                    <p:animEffect transition="in" filter="fade">
+                                      <p:cBhvr>
+                                        <p:cTn id="18" dur="250"/>
+                                        <p:tgtEl>
+                                          <p:spTgt spid="17"/>
+                                        </p:tgtEl>
+                                      </p:cBhvr>
+                                    </p:animEffect>
+                                    <p:anim calcmode="lin" valueType="num">
+                                      <p:cBhvr>
+                                        <p:cTn id="19" dur="250" fill="hold"/>
+                                        <p:tgtEl>
+                                          <p:spTgt spid="17"/>
+                                        </p:tgtEl>
+                                        <p:attrNameLst>
+                                          <p:attrName>ppt_x</p:attrName>
+                                        </p:attrNameLst>
+                                      </p:cBhvr>
+                                      <p:tavLst>
+                                        <p:tav tm="0">
+                                          <p:val>
+                                            <p:strVal val="#ppt_x"/>
+                                          </p:val>
+                                        </p:tav>
+                                        <p:tav tm="100000">
+                                          <p:val>
+                                            <p:strVal val="#ppt_x"/>
+                                          </p:val>
+                                        </p:tav>
+                                      </p:tavLst>
+                                    </p:anim>
+                                    <p:anim calcmode="lin" valueType="num">
+                                      <p:cBhvr>
+                                        <p:cTn id="20" dur="250" fill="hold"/>
+                                        <p:tgtEl>
+                                          <p:spTgt spid="17"/>
+                                        </p:tgtEl>
+                                        <p:attrNameLst>
+                                          <p:attrName>ppt_y</p:attrName>
+                                        </p:attrNameLst>
+                                      </p:cBhvr>
+                                      <p:tavLst>
+                                        <p:tav tm="0">
+                                          <p:val>
+                                            <p:strVal val="#ppt_y+.1"/>
+                                          </p:val>
+                                        </p:tav>
+                                        <p:tav tm="100000">
+                                          <p:val>
+                                            <p:strVal val="#ppt_y"/>
+                                          </p:val>
+                                        </p:tav>
+                                      </p:tavLst>
+                                    </p:anim>
+                                  </p:childTnLst>
+                                </p:cTn>
+                              </p:par>
+                            </p:childTnLst>
+                          </p:cTn>
+                        </p:par>
+                      </p:childTnLst>
+                    </p:cTn>
+                  </p:par>
+                  <p:par>
+                    <p:cTn id="21" fill="hold">
+                      <p:stCondLst>
+                        <p:cond delay="indefinite"/>
+                      </p:stCondLst>
+                      <p:childTnLst>
+                        <p:par>
+                          <p:cTn id="22" fill="hold">
+                            <p:stCondLst>
+                              <p:cond delay="0"/>
+                            </p:stCondLst>
+                            <p:childTnLst>
+                              <p:par>
+                                <p:cTn id="23" presetID="1" presetClass="exit" presetSubtype="0" fill="hold" grpId="1" nodeType="clickEffect">
+                                  <p:stCondLst>
+                                    <p:cond delay="0"/>
+                                  </p:stCondLst>
+                                  <p:childTnLst>
+                                    <p:set>
+                                      <p:cBhvr>
+                                        <p:cTn id="24" dur="1" fill="hold">
+                                          <p:stCondLst>
+                                            <p:cond delay="0"/>
+                                          </p:stCondLst>
+                                        </p:cTn>
+                                        <p:tgtEl>
+                                          <p:spTgt spid="17"/>
+                                        </p:tgtEl>
+                                        <p:attrNameLst>
+                                          <p:attrName>style.visibility</p:attrName>
+                                        </p:attrNameLst>
+                                      </p:cBhvr>
+                                      <p:to>
+                                        <p:strVal val="hidden"/>
+                                      </p:to>
+                                    </p:set>
+                                  </p:childTnLst>
+                                </p:cTn>
+                              </p:par>
+                            </p:childTnLst>
+                          </p:cTn>
+                        </p:par>
+                      </p:childTnLst>
+                    </p:cTn>
+                  </p:par>
+                  <p:par>
+                    <p:cTn id="25" fill="hold">
+                      <p:stCondLst>
+                        <p:cond delay="indefinite"/>
+                      </p:stCondLst>
+                      <p:childTnLst>
+                        <p:par>
+                          <p:cTn id="26" fill="hold">
+                            <p:stCondLst>
+                              <p:cond delay="0"/>
+                            </p:stCondLst>
+                            <p:childTnLst>
+                              <p:par>
+                                <p:cTn id="27" presetID="42" presetClass="entr" presetSubtype="0" fill="hold" grpId="0" nodeType="clickEffect">
+                                  <p:stCondLst>
+                                    <p:cond delay="0"/>
+                                  </p:stCondLst>
+                                  <p:childTnLst>
+                                    <p:set>
+                                      <p:cBhvr>
+                                        <p:cTn id="28" dur="1" fill="hold">
+                                          <p:stCondLst>
+                                            <p:cond delay="0"/>
+                                          </p:stCondLst>
+                                        </p:cTn>
+                                        <p:tgtEl>
+                                          <p:spTgt spid="18"/>
+                                        </p:tgtEl>
+                                        <p:attrNameLst>
+                                          <p:attrName>style.visibility</p:attrName>
+                                        </p:attrNameLst>
+                                      </p:cBhvr>
+                                      <p:to>
+                                        <p:strVal val="visible"/>
+                                      </p:to>
+                                    </p:set>
+                                    <p:animEffect transition="in" filter="fade">
+                                      <p:cBhvr>
+                                        <p:cTn id="29" dur="250"/>
+                                        <p:tgtEl>
+                                          <p:spTgt spid="18"/>
+                                        </p:tgtEl>
+                                      </p:cBhvr>
+                                    </p:animEffect>
+                                    <p:anim calcmode="lin" valueType="num">
+                                      <p:cBhvr>
+                                        <p:cTn id="30" dur="250" fill="hold"/>
+                                        <p:tgtEl>
+                                          <p:spTgt spid="18"/>
+                                        </p:tgtEl>
+                                        <p:attrNameLst>
+                                          <p:attrName>ppt_x</p:attrName>
+                                        </p:attrNameLst>
+                                      </p:cBhvr>
+                                      <p:tavLst>
+                                        <p:tav tm="0">
+                                          <p:val>
+                                            <p:strVal val="#ppt_x"/>
+                                          </p:val>
+                                        </p:tav>
+                                        <p:tav tm="100000">
+                                          <p:val>
+                                            <p:strVal val="#ppt_x"/>
+                                          </p:val>
+                                        </p:tav>
+                                      </p:tavLst>
+                                    </p:anim>
+                                    <p:anim calcmode="lin" valueType="num">
+                                      <p:cBhvr>
+                                        <p:cTn id="31" dur="250" fill="hold"/>
+                                        <p:tgtEl>
+                                          <p:spTgt spid="18"/>
+                                        </p:tgtEl>
+                                        <p:attrNameLst>
+                                          <p:attrName>ppt_y</p:attrName>
+                                        </p:attrNameLst>
+                                      </p:cBhvr>
+                                      <p:tavLst>
+                                        <p:tav tm="0">
+                                          <p:val>
+                                            <p:strVal val="#ppt_y+.1"/>
+                                          </p:val>
+                                        </p:tav>
+                                        <p:tav tm="100000">
+                                          <p:val>
+                                            <p:strVal val="#ppt_y"/>
+                                          </p:val>
+                                        </p:tav>
+                                      </p:tavLst>
+                                    </p:anim>
+                                  </p:childTnLst>
+                                </p:cTn>
+                              </p:par>
+                            </p:childTnLst>
+                          </p:cTn>
+                        </p:par>
+                      </p:childTnLst>
+                    </p:cTn>
+                  </p:par>
+                  <p:par>
+                    <p:cTn id="32" fill="hold">
+                      <p:stCondLst>
+                        <p:cond delay="indefinite"/>
+                      </p:stCondLst>
+                      <p:childTnLst>
+                        <p:par>
+                          <p:cTn id="33" fill="hold">
+                            <p:stCondLst>
+                              <p:cond delay="0"/>
+                            </p:stCondLst>
+                            <p:childTnLst>
+                              <p:par>
+                                <p:cTn id="34" presetID="1" presetClass="exit" presetSubtype="0" fill="hold" grpId="1" nodeType="clickEffect">
+                                  <p:stCondLst>
+                                    <p:cond delay="0"/>
+                                  </p:stCondLst>
+                                  <p:childTnLst>
+                                    <p:set>
+                                      <p:cBhvr>
+                                        <p:cTn id="35" dur="1" fill="hold">
+                                          <p:stCondLst>
+                                            <p:cond delay="0"/>
+                                          </p:stCondLst>
+                                        </p:cTn>
+                                        <p:tgtEl>
+                                          <p:spTgt spid="18"/>
+                                        </p:tgtEl>
+                                        <p:attrNameLst>
+                                          <p:attrName>style.visibility</p:attrName>
+                                        </p:attrNameLst>
+                                      </p:cBhvr>
+                                      <p:to>
+                                        <p:strVal val="hidden"/>
+                                      </p:to>
+                                    </p:set>
+                                  </p:childTnLst>
+                                </p:cTn>
+                              </p:par>
+                            </p:childTnLst>
+                          </p:cTn>
+                        </p:par>
+                      </p:childTnLst>
+                    </p:cTn>
+                  </p:par>
+                  <p:par>
+                    <p:cTn id="36" fill="hold">
+                      <p:stCondLst>
+                        <p:cond delay="indefinite"/>
+                      </p:stCondLst>
+                      <p:childTnLst>
+                        <p:par>
+                          <p:cTn id="37" fill="hold">
+                            <p:stCondLst>
+                              <p:cond delay="0"/>
+                            </p:stCondLst>
+                            <p:childTnLst>
+                              <p:par>
+                                <p:cTn id="38" presetID="42" presetClass="entr" presetSubtype="0" fill="hold" grpId="0" nodeType="clickEffect">
+                                  <p:stCondLst>
+                                    <p:cond delay="0"/>
+                                  </p:stCondLst>
+                                  <p:childTnLst>
+                                    <p:set>
+                                      <p:cBhvr>
+                                        <p:cTn id="39" dur="1" fill="hold">
+                                          <p:stCondLst>
+                                            <p:cond delay="0"/>
+                                          </p:stCondLst>
+                                        </p:cTn>
+                                        <p:tgtEl>
+                                          <p:spTgt spid="19"/>
+                                        </p:tgtEl>
+                                        <p:attrNameLst>
+                                          <p:attrName>style.visibility</p:attrName>
+                                        </p:attrNameLst>
+                                      </p:cBhvr>
+                                      <p:to>
+                                        <p:strVal val="visible"/>
+                                      </p:to>
+                                    </p:set>
+                                    <p:animEffect transition="in" filter="fade">
+                                      <p:cBhvr>
+                                        <p:cTn id="40" dur="250"/>
+                                        <p:tgtEl>
+                                          <p:spTgt spid="19"/>
+                                        </p:tgtEl>
+                                      </p:cBhvr>
+                                    </p:animEffect>
+                                    <p:anim calcmode="lin" valueType="num">
+                                      <p:cBhvr>
+                                        <p:cTn id="41" dur="250" fill="hold"/>
+                                        <p:tgtEl>
+                                          <p:spTgt spid="19"/>
+                                        </p:tgtEl>
+                                        <p:attrNameLst>
+                                          <p:attrName>ppt_x</p:attrName>
+                                        </p:attrNameLst>
+                                      </p:cBhvr>
+                                      <p:tavLst>
+                                        <p:tav tm="0">
+                                          <p:val>
+                                            <p:strVal val="#ppt_x"/>
+                                          </p:val>
+                                        </p:tav>
+                                        <p:tav tm="100000">
+                                          <p:val>
+                                            <p:strVal val="#ppt_x"/>
+                                          </p:val>
+                                        </p:tav>
+                                      </p:tavLst>
+                                    </p:anim>
+                                    <p:anim calcmode="lin" valueType="num">
+                                      <p:cBhvr>
+                                        <p:cTn id="42" dur="250" fill="hold"/>
+                                        <p:tgtEl>
+                                          <p:spTgt spid="19"/>
+                                        </p:tgtEl>
+                                        <p:attrNameLst>
+                                          <p:attrName>ppt_y</p:attrName>
+                                        </p:attrNameLst>
+                                      </p:cBhvr>
+                                      <p:tavLst>
+                                        <p:tav tm="0">
+                                          <p:val>
+                                            <p:strVal val="#ppt_y+.1"/>
+                                          </p:val>
+                                        </p:tav>
+                                        <p:tav tm="100000">
+                                          <p:val>
+                                            <p:strVal val="#ppt_y"/>
+                                          </p:val>
+                                        </p:tav>
+                                      </p:tavLst>
+                                    </p:anim>
+                                  </p:childTnLst>
+                                </p:cTn>
+                              </p:par>
+                            </p:childTnLst>
+                          </p:cTn>
+                        </p:par>
+                      </p:childTnLst>
+                    </p:cTn>
+                  </p:par>
+                  <p:par>
+                    <p:cTn id="43" fill="hold">
+                      <p:stCondLst>
+                        <p:cond delay="indefinite"/>
+                      </p:stCondLst>
+                      <p:childTnLst>
+                        <p:par>
+                          <p:cTn id="44" fill="hold">
+                            <p:stCondLst>
+                              <p:cond delay="0"/>
+                            </p:stCondLst>
+                            <p:childTnLst>
+                              <p:par>
+                                <p:cTn id="45" presetID="1" presetClass="exit" presetSubtype="0" fill="hold" grpId="1" nodeType="clickEffect">
+                                  <p:stCondLst>
+                                    <p:cond delay="0"/>
+                                  </p:stCondLst>
+                                  <p:childTnLst>
+                                    <p:set>
+                                      <p:cBhvr>
+                                        <p:cTn id="46" dur="1" fill="hold">
+                                          <p:stCondLst>
+                                            <p:cond delay="0"/>
+                                          </p:stCondLst>
+                                        </p:cTn>
+                                        <p:tgtEl>
+                                          <p:spTgt spid="19"/>
+                                        </p:tgtEl>
+                                        <p:attrNameLst>
+                                          <p:attrName>style.visibility</p:attrName>
+                                        </p:attrNameLst>
+                                      </p:cBhvr>
+                                      <p:to>
+                                        <p:strVal val="hidden"/>
+                                      </p:to>
+                                    </p:set>
+                                  </p:childTnLst>
+                                </p:cTn>
+                              </p:par>
+                            </p:childTnLst>
+                          </p:cTn>
+                        </p:par>
+                      </p:childTnLst>
+                    </p:cTn>
+                  </p:par>
+                </p:childTnLst>
+              </p:cTn>
+              <p:prevCondLst>
+                <p:cond evt="onPrev" delay="0">
+                  <p:tgtEl>
+                    <p:sldTgt/>
+                  </p:tgtEl>
+                </p:cond>
+              </p:prevCondLst>
+              <p:nextCondLst>
+                <p:cond evt="onNext" delay="0">
+                  <p:tgtEl>
+                    <p:sldTgt/>
+                  </p:tgtEl>
+                </p:cond>
+              </p:nextCondLst>
+            </p:seq>
+          </p:childTnLst>
+        </p:cTn>
+      </p:par>
+    </p:tnLst>
+    <p:bldLst>
+      <p:bldP spid="16" grpId="0" animBg="1"/>
+      <p:bldP spid="16" grpId="1" animBg="1"/>
+      <p:bldP spid="17" grpId="0" animBg="1"/>
+      <p:bldP spid="17" grpId="1" animBg="1"/>
+      <p:bldP spid="18" grpId="0" animBg="1"/>
+      <p:bldP spid="18" grpId="1" animBg="1"/>
+      <p:bldP spid="19" grpId="0" animBg="1"/>
+      <p:bldP spid="19" grpId="1" animBg="1"/>
+    </p:bldLst>
+  </p:timing>
 </p:sld>
 </file>
 
@@ -33931,7 +34608,7 @@
             </a:r>
             <a:r>
               <a:rPr lang="en-US" sz="1400" dirty="0"/>
-              <a:t>[17]Meta, “React,” </a:t>
+              <a:t>Meta, “React,” </a:t>
             </a:r>
             <a:r>
               <a:rPr lang="en-US" sz="1400" dirty="0" err="1"/>

</xml_diff>

<commit_message>
small spelling fix in ppt
</commit_message>
<xml_diff>
--- a/MP2526_Verdediging.pptx
+++ b/MP2526_Verdediging.pptx
@@ -7498,15 +7498,7 @@
           </a:r>
           <a:r>
             <a:rPr lang="nl-BE" dirty="0"/>
-            <a:t> </a:t>
-          </a:r>
-          <a:r>
-            <a:rPr lang="nl-BE" dirty="0" err="1"/>
-            <a:t>Quiestionnaire</a:t>
-          </a:r>
-          <a:r>
-            <a:rPr lang="nl-BE" dirty="0"/>
-            <a:t> (UEQ) [14]</a:t>
+            <a:t> Questionnaire (UEQ) [14]</a:t>
           </a:r>
           <a:endParaRPr lang="en-US" dirty="0"/>
         </a:p>
@@ -7579,21 +7571,14 @@
         <a:lstStyle/>
         <a:p>
           <a:r>
-            <a:rPr lang="en-US" dirty="0" err="1"/>
-            <a:t>Ondertekende</a:t>
-          </a:r>
-          <a:r>
             <a:rPr lang="en-US" dirty="0"/>
-            <a:t> </a:t>
+            <a:t>Informed </a:t>
           </a:r>
           <a:r>
             <a:rPr lang="en-US" dirty="0" err="1"/>
-            <a:t>een</a:t>
+            <a:t>consentformulier</a:t>
           </a:r>
-          <a:r>
-            <a:rPr lang="en-US" dirty="0"/>
-            <a:t> informed consent</a:t>
-          </a:r>
+          <a:endParaRPr lang="en-US" dirty="0"/>
         </a:p>
       </dgm:t>
     </dgm:pt>
@@ -8293,7 +8278,7 @@
 <dgm:dataModel xmlns:dgm="http://schemas.openxmlformats.org/drawingml/2006/diagram" xmlns:a="http://schemas.openxmlformats.org/drawingml/2006/main">
   <dgm:ptLst>
     <dgm:pt modelId="{424BC47A-3345-48C8-A87F-D6E04AAA26E9}" type="doc">
-      <dgm:prSet loTypeId="urn:microsoft.com/office/officeart/2005/8/layout/vList2" loCatId="list" qsTypeId="urn:microsoft.com/office/officeart/2005/8/quickstyle/simple1" qsCatId="simple" csTypeId="urn:microsoft.com/office/officeart/2005/8/colors/accent1_2" csCatId="accent1"/>
+      <dgm:prSet loTypeId="urn:microsoft.com/office/officeart/2005/8/layout/vList2" loCatId="list" qsTypeId="urn:microsoft.com/office/officeart/2005/8/quickstyle/simple1" qsCatId="simple" csTypeId="urn:microsoft.com/office/officeart/2005/8/colors/accent1_2" csCatId="accent1" phldr="1"/>
       <dgm:spPr/>
       <dgm:t>
         <a:bodyPr/>
@@ -8373,7 +8358,7 @@
         <a:p>
           <a:r>
             <a:rPr lang="nl-BE" sz="2000" dirty="0"/>
-            <a:t>Node-creatie</a:t>
+            <a:t>Node-creatie/-deletie</a:t>
           </a:r>
           <a:endParaRPr lang="en-US" sz="2000" dirty="0"/>
         </a:p>
@@ -11489,21 +11474,14 @@
             <a:buChar char="•"/>
           </a:pPr>
           <a:r>
-            <a:rPr lang="en-US" sz="2200" kern="1200" dirty="0" err="1"/>
-            <a:t>Ondertekende</a:t>
-          </a:r>
-          <a:r>
             <a:rPr lang="en-US" sz="2200" kern="1200" dirty="0"/>
-            <a:t> </a:t>
+            <a:t>Informed </a:t>
           </a:r>
           <a:r>
             <a:rPr lang="en-US" sz="2200" kern="1200" dirty="0" err="1"/>
-            <a:t>een</a:t>
+            <a:t>consentformulier</a:t>
           </a:r>
-          <a:r>
-            <a:rPr lang="en-US" sz="2200" kern="1200" dirty="0"/>
-            <a:t> informed consent</a:t>
-          </a:r>
+          <a:endParaRPr lang="en-US" sz="2200" kern="1200" dirty="0"/>
         </a:p>
       </dsp:txBody>
       <dsp:txXfrm>
@@ -11702,15 +11680,7 @@
           </a:r>
           <a:r>
             <a:rPr lang="nl-BE" sz="2200" kern="1200" dirty="0"/>
-            <a:t> </a:t>
-          </a:r>
-          <a:r>
-            <a:rPr lang="nl-BE" sz="2200" kern="1200" dirty="0" err="1"/>
-            <a:t>Quiestionnaire</a:t>
-          </a:r>
-          <a:r>
-            <a:rPr lang="nl-BE" sz="2200" kern="1200" dirty="0"/>
-            <a:t> (UEQ) [14]</a:t>
+            <a:t> Questionnaire (UEQ) [14]</a:t>
           </a:r>
           <a:endParaRPr lang="en-US" sz="2200" kern="1200" dirty="0"/>
         </a:p>
@@ -12563,7 +12533,7 @@
           </a:pPr>
           <a:r>
             <a:rPr lang="nl-BE" sz="2000" kern="1200" dirty="0"/>
-            <a:t>Node-creatie</a:t>
+            <a:t>Node-creatie/-deletie</a:t>
           </a:r>
           <a:endParaRPr lang="en-US" sz="2000" kern="1200" dirty="0"/>
         </a:p>
@@ -32247,7 +32217,7 @@
             <p:ph idx="1"/>
             <p:extLst>
               <p:ext uri="{D42A27DB-BD31-4B8C-83A1-F6EECF244321}">
-                <p14:modId xmlns:p14="http://schemas.microsoft.com/office/powerpoint/2010/main" val="2718585810"/>
+                <p14:modId xmlns:p14="http://schemas.microsoft.com/office/powerpoint/2010/main" val="3978550204"/>
               </p:ext>
             </p:extLst>
           </p:nvPr>
@@ -32455,8 +32425,8 @@
         </p:blipFill>
         <p:spPr>
           <a:xfrm>
-            <a:off x="609600" y="2193787"/>
-            <a:ext cx="5384800" cy="2719323"/>
+            <a:off x="85659" y="1736811"/>
+            <a:ext cx="6701738" cy="3384376"/>
           </a:xfrm>
           <a:prstGeom prst="rect">
             <a:avLst/>
@@ -32518,8 +32488,8 @@
         </p:nvSpPr>
         <p:spPr>
           <a:xfrm>
-            <a:off x="6197602" y="980731"/>
-            <a:ext cx="5384800" cy="5145435"/>
+            <a:off x="6721541" y="2204865"/>
+            <a:ext cx="5384800" cy="2448269"/>
           </a:xfrm>
         </p:spPr>
         <p:txBody>
@@ -32578,7 +32548,7 @@
         </p:nvSpPr>
         <p:spPr>
           <a:xfrm>
-            <a:off x="609598" y="4797152"/>
+            <a:off x="623392" y="4951910"/>
             <a:ext cx="5342386" cy="338554"/>
           </a:xfrm>
           <a:prstGeom prst="rect">
@@ -33487,7 +33457,7 @@
             <p:ph sz="half" idx="10"/>
             <p:extLst>
               <p:ext uri="{D42A27DB-BD31-4B8C-83A1-F6EECF244321}">
-                <p14:modId xmlns:p14="http://schemas.microsoft.com/office/powerpoint/2010/main" val="3389578620"/>
+                <p14:modId xmlns:p14="http://schemas.microsoft.com/office/powerpoint/2010/main" val="874378001"/>
               </p:ext>
             </p:extLst>
           </p:nvPr>

</xml_diff>

<commit_message>
changed picture in ppt
</commit_message>
<xml_diff>
--- a/MP2526_Verdediging.pptx
+++ b/MP2526_Verdediging.pptx
@@ -29854,9 +29854,9 @@
         <p:grpSpPr>
           <a:xfrm>
             <a:off x="251302" y="1268760"/>
-            <a:ext cx="5405118" cy="3312368"/>
+            <a:ext cx="5405118" cy="3298509"/>
             <a:chOff x="0" y="0"/>
-            <a:chExt cx="2971800" cy="1821180"/>
+            <a:chExt cx="2971800" cy="1813560"/>
           </a:xfrm>
         </p:grpSpPr>
         <p:pic>
@@ -29931,42 +29931,6 @@
         </p:pic>
         <p:pic>
           <p:nvPicPr>
-            <p:cNvPr id="7" name="Afbeelding 6" descr="Afbeelding met schermopname, clipart, ontwerp&#10;&#10;Door AI gegenereerde inhoud is mogelijk onjuist.">
-              <a:extLst>
-                <a:ext uri="{FF2B5EF4-FFF2-40B4-BE49-F238E27FC236}">
-                  <a16:creationId xmlns:a16="http://schemas.microsoft.com/office/drawing/2014/main" id="{20C45C50-845A-86B0-BA24-2F669D8B8FB8}"/>
-                </a:ext>
-              </a:extLst>
-            </p:cNvPr>
-            <p:cNvPicPr>
-              <a:picLocks noChangeAspect="1"/>
-            </p:cNvPicPr>
-            <p:nvPr/>
-          </p:nvPicPr>
-          <p:blipFill>
-            <a:blip r:embed="rId5">
-              <a:extLst>
-                <a:ext uri="{28A0092B-C50C-407E-A947-70E740481C1C}">
-                  <a14:useLocalDpi xmlns:a14="http://schemas.microsoft.com/office/drawing/2010/main" val="0"/>
-                </a:ext>
-              </a:extLst>
-            </a:blip>
-            <a:stretch>
-              <a:fillRect/>
-            </a:stretch>
-          </p:blipFill>
-          <p:spPr>
-            <a:xfrm>
-              <a:off x="2125980" y="1051560"/>
-              <a:ext cx="838200" cy="769620"/>
-            </a:xfrm>
-            <a:prstGeom prst="rect">
-              <a:avLst/>
-            </a:prstGeom>
-          </p:spPr>
-        </p:pic>
-        <p:pic>
-          <p:nvPicPr>
             <p:cNvPr id="8" name="Afbeelding 7" descr="Afbeelding met schermopname, diagram, symbool, ontwerp&#10;&#10;Door AI gegenereerde inhoud is mogelijk onjuist.">
               <a:extLst>
                 <a:ext uri="{FF2B5EF4-FFF2-40B4-BE49-F238E27FC236}">
@@ -29980,7 +29944,7 @@
             <p:nvPr/>
           </p:nvPicPr>
           <p:blipFill>
-            <a:blip r:embed="rId6">
+            <a:blip r:embed="rId5">
               <a:extLst>
                 <a:ext uri="{28A0092B-C50C-407E-A947-70E740481C1C}">
                   <a14:useLocalDpi xmlns:a14="http://schemas.microsoft.com/office/drawing/2010/main" val="0"/>
@@ -30353,7 +30317,7 @@
           <p:nvPr/>
         </p:nvPicPr>
         <p:blipFill>
-          <a:blip r:embed="rId7"/>
+          <a:blip r:embed="rId6"/>
           <a:stretch>
             <a:fillRect/>
           </a:stretch>
@@ -30596,6 +30560,36 @@
           </a:p>
         </p:txBody>
       </p:sp>
+      <p:pic>
+        <p:nvPicPr>
+          <p:cNvPr id="21" name="Afbeelding 20" descr="Afbeelding met tekst, schermopname, Lettertype, diagram&#10;&#10;Door AI gegenereerde inhoud is mogelijk onjuist.">
+            <a:extLst>
+              <a:ext uri="{FF2B5EF4-FFF2-40B4-BE49-F238E27FC236}">
+                <a16:creationId xmlns:a16="http://schemas.microsoft.com/office/drawing/2014/main" id="{A058C131-0103-A0D1-F19E-D52E2F2D0D9A}"/>
+              </a:ext>
+            </a:extLst>
+          </p:cNvPr>
+          <p:cNvPicPr>
+            <a:picLocks noChangeAspect="1"/>
+          </p:cNvPicPr>
+          <p:nvPr/>
+        </p:nvPicPr>
+        <p:blipFill>
+          <a:blip r:embed="rId7"/>
+          <a:stretch>
+            <a:fillRect/>
+          </a:stretch>
+        </p:blipFill>
+        <p:spPr>
+          <a:xfrm>
+            <a:off x="4128823" y="3282351"/>
+            <a:ext cx="1491665" cy="1298777"/>
+          </a:xfrm>
+          <a:prstGeom prst="rect">
+            <a:avLst/>
+          </a:prstGeom>
+        </p:spPr>
+      </p:pic>
     </p:spTree>
     <p:extLst>
       <p:ext uri="{BB962C8B-B14F-4D97-AF65-F5344CB8AC3E}">

</xml_diff>